<commit_message>
Deck: say fairness not accuracy, name the closest related work, state limitations
- Slide 3: "92% of the lost fairness (USR)", not "accuracy".
- Literature slide: adds Rath & Maliakkal 2026 (same setup as ours, detection
  only), Hua et al. COLM 2026, Critical Weight Protection 2026 (closest method:
  static, 60% of weights in FP16) and Q-resafe; speaker notes say how this
  project differs from each.
- Slide 8: Gender identity (85% recovered) shown as a limitation; notes add the
  per-group finding (8 of 23 groups end more stereotyped than the original),
  the search-sample fit (84% vs 77%), and "p < 10^-300, never p = 0".

Co-Authored-By: Claude Opus 5.5 <noreply@anthropic.com>
</commit_message>
<xml_diff>
--- a/deck/ELSEM3_deck.pptx
+++ b/deck/ELSEM3_deck.pptx
@@ -1039,7 +1039,7 @@
           <a:p>
             <a:r>
               <a:rPr lang="en-US" dirty="0"/>
-              <a:t>Draft built from the project brief. Before Week 7: (1) reconcile with the team's literature notes; (2) add the fairness-specific static-protection paper(s) the brief refers to, since the middle column currently cites accuracy-oriented mixed-precision methods; (3) check every venue/year against the actual papers. HQQ: Badri &amp; Shaji, Mobius Labs, 2023. Phi-3: Abdin et al., Phi-3 Technical Report, 2024.</a:t>
+              <a:t>How we differ: Rath &amp; Maliakkal (arXiv 2605.15208) detect the same damage on our exact setup but don't repair it. Critical Weight Protection (arXiv 2601.12033) is the closest method: per-weight gradient scores, static, at quantization time, 60% of weights kept in FP16 -- ours repairs after compression, from the failing examples, 3.4% of weights, no retraining. Q-resafe (arXiv 2506.20251) repairs after compression but for safety and with DPO/LoRA training. Accuracy-oriented mixed precision (LLM.int8, SpQR, AWQ) protects weights for accuracy, not fairness. Hu &amp; Ramachandran (arXiv 2609.01587) show general-ability damage is diffuse -- the basis for our concentrated-vs-diffuse comparison. HQQ: Badri &amp; Shaji, Mobius Labs, 2023. Phi-3: Abdin et al., Phi-3 Technical Report, 2024.</a:t>
             </a:r>
             <a:endParaRPr lang="en-US" dirty="0"/>
           </a:p>
@@ -1215,7 +1215,7 @@
           <a:p>
             <a:r>
               <a:rPr lang="en-US" dirty="0"/>
-              <a:t>Figure: results/figures/conditions_usr.png. Full per-category table with CIs: results/figures/results_table.md. Honest caveat for Q&amp;A: repair overshoots baseline on Age but leaves Gender_identity ~8 points short.</a:t>
+              <a:t>Figure: results/figures/conditions_usr.png. Full per-category table with CIs: results/figures/results_table.md. Honest caveats for Q&amp;A: (1) repair overshoots baseline on Age but leaves Gender_identity ~8 points short (85% recovered). (2) Per targeted group (python -m src.stats.groups), 8 of 23 groups end significantly MORE stereotyped than the original model after repair, e.g. women 11.8% -&gt; 17.0%, Hispanic/Latino 5.4% -&gt; 11.0%. (3) The repair moves 84% of the 300 flipped questions the search saw back to 'unknown' vs 77% of the 3,092 it never saw: real, modest fitting to the sample. (4) If a chi-squared p-value is shown, write p &lt; 10^-300, never p = 0.</a:t>
             </a:r>
             <a:endParaRPr lang="en-US" dirty="0"/>
           </a:p>
@@ -3338,7 +3338,7 @@
                 <a:ea typeface="Calibri" pitchFamily="34" charset="-122"/>
                 <a:cs typeface="Calibri" pitchFamily="34" charset="-120"/>
               </a:rPr>
-              <a:t>of the lost accuracy recovered by restoring 5 of 128 modules (3.4% of weights, +70 MB)</a:t>
+              <a:t>of the lost fairness (USR) recovered by restoring 5 of 128 modules (3.4% of weights, +70 MB)</a:t>
             </a:r>
             <a:endParaRPr lang="en-US" sz="1500" dirty="0"/>
           </a:p>
@@ -4440,7 +4440,7 @@
                 <a:ea typeface="Calibri" pitchFamily="34" charset="-122"/>
                 <a:cs typeface="Calibri" pitchFamily="34" charset="-120"/>
               </a:rPr>
-              <a:t>Gonçalves &amp; Strubell (EMNLP 2023): compression changes social bias in LLMs. BBQ (Parrish et al., ACL Findings 2022) is the benchmark.</a:t>
+              <a:t>Gonçalves &amp; Strubell (EMNLP 2023); Hua et al. (COLM 2026): bias flips hidden by averages. Rath &amp; Maliakkal (2026): same model, BBQ and 3-bit as ours, detection only.</a:t>
             </a:r>
             <a:endParaRPr lang="en-US" sz="1100" dirty="0"/>
           </a:p>
@@ -4584,7 +4584,7 @@
                 <a:ea typeface="Calibri" pitchFamily="34" charset="-122"/>
                 <a:cs typeface="Calibri" pitchFamily="34" charset="-120"/>
               </a:rPr>
-              <a:t>LLM.int8() (Dettmers et al., NeurIPS 2022), SpQR (Dettmers et al., ICLR 2024), AWQ (Lin et al., MLSys 2024) keep salient weights at high precision, picked for accuracy up front.</a:t>
+              <a:t>Critical Weight Protection (Al Hakim et al., 2026) keeps fairness-critical weights (top 60%) in FP16 at quantization time; Q-resafe (ICML 2025) patches safety with retraining.</a:t>
             </a:r>
             <a:endParaRPr lang="en-US" sz="1100" dirty="0"/>
           </a:p>
@@ -6243,6 +6243,45 @@
       <p:sp>
         <p:nvSpPr>
           <p:cNvPr id="12" name="Text 9"/>
+          <p:cNvSpPr txBox="1"/>
+          <p:nvPr/>
+        </p:nvSpPr>
+        <p:spPr>
+          <a:xfrm>
+            <a:off x="6400800" y="4434840"/>
+            <a:ext cx="2377440" cy="274320"/>
+          </a:xfrm>
+          <a:prstGeom prst="rect">
+            <a:avLst/>
+          </a:prstGeom>
+          <a:noFill/>
+          <a:ln/>
+        </p:spPr>
+        <p:txBody>
+          <a:bodyPr wrap="square" lIns="0" tIns="0" rIns="0" bIns="0" rtlCol="0" anchor="ctr"/>
+          <a:lstStyle/>
+          <a:p>
+            <a:pPr indent="0" marL="0">
+              <a:buNone/>
+            </a:pPr>
+            <a:r>
+              <a:rPr lang="en-US" sz="1000" dirty="0">
+                <a:solidFill>
+                  <a:srgbClr val="C0392B"/>
+                </a:solidFill>
+                <a:latin typeface="Calibri" pitchFamily="34" charset="0"/>
+                <a:ea typeface="Calibri" pitchFamily="34" charset="-122"/>
+                <a:cs typeface="Calibri" pitchFamily="34" charset="-120"/>
+              </a:rPr>
+              <a:t>Limitation: Gender identity recovers least (85%).</a:t>
+            </a:r>
+            <a:endParaRPr lang="en-US" sz="1000" dirty="0"/>
+          </a:p>
+        </p:txBody>
+      </p:sp>
+      <p:sp>
+        <p:nvSpPr>
+          <p:cNvPr id="13" name="Text 10"/>
           <p:cNvSpPr txBox="1"/>
           <p:nvPr/>
         </p:nvSpPr>

</xml_diff>

<commit_message>
Make the hedging-aware repair the project's main result
results/reference/MAIN_REPAIR.json names the main repair (the hedging-penalty search's 5 attention
modules, results/patches/hedging_penalty.json) and keeps search_top5 as `previous`. The final tables,
FairGate report, Studio, groups, sensitivity, figures and deck all read it through
src/experiments/main_repair.py, so they can't disagree.

Main repair: 86% [84, 87] of the lost "unknown" back, 10.9% false "unknown" on stated-answer
questions (original 7.3%, first repair 20.3%), combined recovery 75% (first repair 64%), +81 MB.
The same-size baselines stay labelled as the first repair's comparison. Studio's guide, Ship verdict
and the deck's notes no longer hard-code the first repair's numbers.

Co-Authored-By: Claude Opus 5.5 <noreply@anthropic.com>
</commit_message>
<xml_diff>
--- a/deck/ELSEM3_deck.pptx
+++ b/deck/ELSEM3_deck.pptx
@@ -1039,7 +1039,7 @@
           <a:p>
             <a:r>
               <a:rPr lang="en-US" dirty="0"/>
-              <a:t>How we differ: Rath &amp; Maliakkal (arXiv 2605.15208) detect the same damage on our exact setup but don't repair it. Critical Weight Protection (arXiv 2601.12033) is the closest method: per-weight gradient scores, static, at quantization time, 60% of weights kept in FP16 -- ours repairs after compression, from the failing examples, 3.4% of weights, no retraining. Q-resafe (arXiv 2506.20251) repairs after compression but for safety and with DPO/LoRA training. Accuracy-oriented mixed precision (LLM.int8, SpQR, AWQ) protects weights for accuracy, not fairness. Hu &amp; Ramachandran (arXiv 2609.01587) show general-ability damage is diffuse -- the basis for our concentrated-vs-diffuse comparison. HQQ: Badri &amp; Shaji, Mobius Labs, 2023. Phi-3: Abdin et al., Phi-3 Technical Report, 2024.</a:t>
+              <a:t>How we differ: Rath &amp; Maliakkal (arXiv 2605.15208) detect the same damage on our exact setup but don't repair it. Critical Weight Protection (arXiv 2601.12033) is the closest method: per-weight gradient scores, static, at quantization time, 60% of weights kept in FP16 -- ours repairs after compression, from the failing examples, 3.9% of weights, no retraining. Q-resafe (arXiv 2506.20251) repairs after compression but for safety and with DPO/LoRA training. Accuracy-oriented mixed precision (LLM.int8, SpQR, AWQ) protects weights for accuracy, not fairness. Hu &amp; Ramachandran (arXiv 2609.01587) show general-ability damage is diffuse -- the basis for our concentrated-vs-diffuse comparison. HQQ: Badri &amp; Shaji, Mobius Labs, 2023. Phi-3: Abdin et al., Phi-3 Technical Report, 2024.</a:t>
             </a:r>
             <a:endParaRPr lang="en-US" dirty="0"/>
           </a:p>
@@ -1215,7 +1215,7 @@
           <a:p>
             <a:r>
               <a:rPr lang="en-US" dirty="0"/>
-              <a:t>Figure: results/figures/conditions_usr.png. Full per-category table with CIs: results/figures/results_table.md. Honest caveats for Q&amp;A: (1) repair overshoots baseline on Age but leaves Gender_identity ~8 points short (85% recovered). (2) Per targeted group (python -m src.stats.groups), 8 of 23 groups end significantly MORE stereotyped than the original model after repair, e.g. women 11.8% -&gt; 17.0%, Hispanic/Latino 5.4% -&gt; 11.0%. (3) The repair moves 84% of the 300 flipped questions the search saw back to 'unknown' vs 77% of the 3,092 it never saw: real, modest fitting to the sample. (4) If a chi-squared p-value is shown, write p &lt; 10^-300, never p = 0.</a:t>
+              <a:t>Figure: results/figures/conditions_usr.png. Full per-category table with CIs: results/figures/results_table.md. Honest caveats for Q&amp;A: (0) This is the hedging-aware repair. The first search's repair recovered 92% but said 'unknown' on 20.3% of questions whose story states the answer (original 7.3%); re-running the search with a hedging penalty gives 86% with 10.9%, and better accuracy there than plain 3-bit (83.7% vs 80.8%). (1) Gender_identity recovers least (80%), Age most (97%). (2) Per targeted group (python -m src.stats.groups), 9 of 23 groups end significantly MORE stereotyped than the original model after repair, e.g. women 11.8% -&gt; 18.9%, Hispanic/Latino 5.4% -&gt; 12.5%. (3) The repair moves 77% of the 300 flipped questions the search saw back to 'unknown' vs 72% of the 3,092 it never saw: real, modest fitting to the sample. (4) The FairGate gate still FAILS: 'unknown' 6.7 points below the original, stereotyped answers 2.5 points above. (5) If a chi-squared p-value is shown, write p &lt; 10^-300, never p = 0.</a:t>
             </a:r>
             <a:endParaRPr lang="en-US" dirty="0"/>
           </a:p>
@@ -3299,7 +3299,7 @@
                 <a:ea typeface="Cambria" pitchFamily="34" charset="-122"/>
                 <a:cs typeface="Cambria" pitchFamily="34" charset="-120"/>
               </a:rPr>
-              <a:t>92%</a:t>
+              <a:t>86%</a:t>
             </a:r>
             <a:endParaRPr lang="en-US" sz="3400" dirty="0"/>
           </a:p>
@@ -3338,7 +3338,7 @@
                 <a:ea typeface="Calibri" pitchFamily="34" charset="-122"/>
                 <a:cs typeface="Calibri" pitchFamily="34" charset="-120"/>
               </a:rPr>
-              <a:t>of the lost fairness (USR) recovered by restoring 5 of 128 modules (3.4% of weights, +70 MB)</a:t>
+              <a:t>of the lost fairness (USR) recovered by restoring 5 of 128 modules (3.9% of weights, +81 MB)</a:t>
             </a:r>
             <a:endParaRPr lang="en-US" sz="1500" dirty="0"/>
           </a:p>
@@ -6156,7 +6156,7 @@
                 <a:ea typeface="Cambria" pitchFamily="34" charset="-122"/>
                 <a:cs typeface="Cambria" pitchFamily="34" charset="-120"/>
               </a:rPr>
-              <a:t>80.4%</a:t>
+              <a:t>77.3%</a:t>
             </a:r>
             <a:endParaRPr lang="en-US" sz="2800" dirty="0"/>
           </a:p>
@@ -6234,7 +6234,7 @@
                 <a:ea typeface="Calibri" pitchFamily="34" charset="-122"/>
                 <a:cs typeface="Calibri" pitchFamily="34" charset="-120"/>
               </a:rPr>
-              <a:t>5 modules · 3.4% of weights · +70 MB</a:t>
+              <a:t>5 modules · 3.9% of weights · +81 MB</a:t>
             </a:r>
             <a:endParaRPr lang="en-US" sz="1200" dirty="0"/>
           </a:p>
@@ -6273,7 +6273,7 @@
                 <a:ea typeface="Calibri" pitchFamily="34" charset="-122"/>
                 <a:cs typeface="Calibri" pitchFamily="34" charset="-120"/>
               </a:rPr>
-              <a:t>Limitation: Gender identity recovers least (85%).</a:t>
+              <a:t>Limitation: Gender identity recovers least (80%).</a:t>
             </a:r>
             <a:endParaRPr lang="en-US" sz="1000" dirty="0"/>
           </a:p>

</xml_diff>